<commit_message>
Deck: QR code to the live demo, and numbers measured against the library
The closing slide carried the URL as text, which nobody types. It now shows a
high-error-correction QR alongside it, so the room can scan the code and run the
comparison on their own phones while questions are taken.

Slide 5 is re-measured against the file library rather than the retired single
fixed file: 21.32s on one connection versus 2.61s across eight, on the 8.97 MB
photograph, hashes identical.
</commit_message>
<xml_diff>
--- a/CompletableFuture-Presentation.pptx
+++ b/CompletableFuture-Presentation.pptx
@@ -910,7 +910,7 @@
           <a:p>
             <a:r>
               <a:rPr lang="en-US" dirty="0"/>
-              <a:t>Land on the first and third. Those are judgement, not syntax. Then open it up.</a:t>
+              <a:t>Land on the first and third: those are judgement, not syntax. Then put this slide up and leave it up - people can scan the code and run the comparison on their own phones while you take questions, which is a far better closing image than a bulleted summary.</a:t>
             </a:r>
             <a:endParaRPr lang="en-US" dirty="0"/>
           </a:p>
@@ -1262,7 +1262,7 @@
           <a:p>
             <a:r>
               <a:rPr lang="en-US" dirty="0"/>
-              <a:t>These are the real numbers from concurrency-demo.onrender.com. If the live demo runs, they will differ slightly — say so, that is honest and it proves the numbers are real.</a:t>
+              <a:t>Real measured numbers against the deployed server. The live page offers a small library - two photographs and a video - so you can let the room pick which file to race. If the live demo runs, they will differ slightly — say so, that is honest and it proves the numbers are real.</a:t>
             </a:r>
             <a:endParaRPr lang="en-US" dirty="0"/>
           </a:p>
@@ -2416,7 +2416,7 @@
         </p:nvSpPr>
         <p:spPr>
           <a:xfrm>
-            <a:off x="822960" y="1828800"/>
+            <a:off x="822960" y="1691640"/>
             <a:ext cx="384048" cy="41148"/>
           </a:xfrm>
           <a:prstGeom prst="rect">
@@ -2436,7 +2436,7 @@
         </p:nvSpPr>
         <p:spPr>
           <a:xfrm>
-            <a:off x="822960" y="2029968"/>
+            <a:off x="822960" y="1892808"/>
             <a:ext cx="5029200" cy="384048"/>
           </a:xfrm>
           <a:prstGeom prst="rect">
@@ -2475,8 +2475,8 @@
         </p:nvSpPr>
         <p:spPr>
           <a:xfrm>
-            <a:off x="822960" y="2468880"/>
-            <a:ext cx="5029200" cy="868680"/>
+            <a:off x="822960" y="2295144"/>
+            <a:ext cx="5029200" cy="822960"/>
           </a:xfrm>
           <a:prstGeom prst="rect">
             <a:avLst/>
@@ -2492,7 +2492,7 @@
               <a:buNone/>
             </a:pPr>
             <a:r>
-              <a:rPr lang="en-US" sz="1350" dirty="0">
+              <a:rPr lang="en-US" sz="1250" dirty="0">
                 <a:solidFill>
                   <a:srgbClr val="9FB0BF"/>
                 </a:solidFill>
@@ -2502,7 +2502,7 @@
               </a:rPr>
               <a:t>CompletableFuture wins exactly where threads sit blocked on I/O. It will never make your CPU faster.</a:t>
             </a:r>
-            <a:endParaRPr lang="en-US" sz="1350" dirty="0"/>
+            <a:endParaRPr lang="en-US" sz="1250" dirty="0"/>
           </a:p>
         </p:txBody>
       </p:sp>
@@ -2514,7 +2514,7 @@
         </p:nvSpPr>
         <p:spPr>
           <a:xfrm>
-            <a:off x="6355080" y="1828800"/>
+            <a:off x="6355080" y="1691640"/>
             <a:ext cx="384048" cy="41148"/>
           </a:xfrm>
           <a:prstGeom prst="rect">
@@ -2534,7 +2534,7 @@
         </p:nvSpPr>
         <p:spPr>
           <a:xfrm>
-            <a:off x="6355080" y="2029968"/>
+            <a:off x="6355080" y="1892808"/>
             <a:ext cx="5029200" cy="384048"/>
           </a:xfrm>
           <a:prstGeom prst="rect">
@@ -2573,8 +2573,8 @@
         </p:nvSpPr>
         <p:spPr>
           <a:xfrm>
-            <a:off x="6355080" y="2468880"/>
-            <a:ext cx="5029200" cy="868680"/>
+            <a:off x="6355080" y="2295144"/>
+            <a:ext cx="5029200" cy="822960"/>
           </a:xfrm>
           <a:prstGeom prst="rect">
             <a:avLst/>
@@ -2590,7 +2590,7 @@
               <a:buNone/>
             </a:pPr>
             <a:r>
-              <a:rPr lang="en-US" sz="1350" dirty="0">
+              <a:rPr lang="en-US" sz="1250" dirty="0">
                 <a:solidFill>
                   <a:srgbClr val="9FB0BF"/>
                 </a:solidFill>
@@ -2600,7 +2600,7 @@
               </a:rPr>
               <a:t>Eight threads, eight offsets, one matching hash. Design so the parallel parts cannot collide.</a:t>
             </a:r>
-            <a:endParaRPr lang="en-US" sz="1350" dirty="0"/>
+            <a:endParaRPr lang="en-US" sz="1250" dirty="0"/>
           </a:p>
         </p:txBody>
       </p:sp>
@@ -2612,7 +2612,7 @@
         </p:nvSpPr>
         <p:spPr>
           <a:xfrm>
-            <a:off x="822960" y="3794760"/>
+            <a:off x="822960" y="3264408"/>
             <a:ext cx="384048" cy="41148"/>
           </a:xfrm>
           <a:prstGeom prst="rect">
@@ -2632,7 +2632,7 @@
         </p:nvSpPr>
         <p:spPr>
           <a:xfrm>
-            <a:off x="822960" y="3995928"/>
+            <a:off x="822960" y="3465576"/>
             <a:ext cx="5029200" cy="384048"/>
           </a:xfrm>
           <a:prstGeom prst="rect">
@@ -2671,8 +2671,8 @@
         </p:nvSpPr>
         <p:spPr>
           <a:xfrm>
-            <a:off x="822960" y="4434840"/>
-            <a:ext cx="5029200" cy="868680"/>
+            <a:off x="822960" y="3867912"/>
+            <a:ext cx="5029200" cy="822960"/>
           </a:xfrm>
           <a:prstGeom prst="rect">
             <a:avLst/>
@@ -2688,7 +2688,7 @@
               <a:buNone/>
             </a:pPr>
             <a:r>
-              <a:rPr lang="en-US" sz="1350" dirty="0">
+              <a:rPr lang="en-US" sz="1250" dirty="0">
                 <a:solidFill>
                   <a:srgbClr val="9FB0BF"/>
                 </a:solidFill>
@@ -2698,7 +2698,7 @@
               </a:rPr>
               <a:t>Never blocking work on the common pool. Name the threads, size the pool to the work, shut it down in a finally.</a:t>
             </a:r>
-            <a:endParaRPr lang="en-US" sz="1350" dirty="0"/>
+            <a:endParaRPr lang="en-US" sz="1250" dirty="0"/>
           </a:p>
         </p:txBody>
       </p:sp>
@@ -2710,7 +2710,7 @@
         </p:nvSpPr>
         <p:spPr>
           <a:xfrm>
-            <a:off x="6355080" y="3794760"/>
+            <a:off x="6355080" y="3264408"/>
             <a:ext cx="384048" cy="41148"/>
           </a:xfrm>
           <a:prstGeom prst="rect">
@@ -2730,7 +2730,7 @@
         </p:nvSpPr>
         <p:spPr>
           <a:xfrm>
-            <a:off x="6355080" y="3995928"/>
+            <a:off x="6355080" y="3465576"/>
             <a:ext cx="5029200" cy="384048"/>
           </a:xfrm>
           <a:prstGeom prst="rect">
@@ -2769,8 +2769,8 @@
         </p:nvSpPr>
         <p:spPr>
           <a:xfrm>
-            <a:off x="6355080" y="4434840"/>
-            <a:ext cx="5029200" cy="868680"/>
+            <a:off x="6355080" y="3867912"/>
+            <a:ext cx="5029200" cy="822960"/>
           </a:xfrm>
           <a:prstGeom prst="rect">
             <a:avLst/>
@@ -2786,7 +2786,7 @@
               <a:buNone/>
             </a:pPr>
             <a:r>
-              <a:rPr lang="en-US" sz="1350" dirty="0">
+              <a:rPr lang="en-US" sz="1250" dirty="0">
                 <a:solidFill>
                   <a:srgbClr val="9FB0BF"/>
                 </a:solidFill>
@@ -2796,19 +2796,70 @@
               </a:rPr>
               <a:t>thenCompose and thenCombine to build it, exceptionally and orTimeout to survive it, one join() to collect it.</a:t>
             </a:r>
-            <a:endParaRPr lang="en-US" sz="1350" dirty="0"/>
-          </a:p>
-        </p:txBody>
-      </p:sp>
-      <p:sp>
-        <p:nvSpPr>
-          <p:cNvPr id="15" name="Text 13"/>
-          <p:cNvSpPr txBox="1"/>
-          <p:nvPr/>
-        </p:nvSpPr>
-        <p:spPr>
-          <a:xfrm>
-            <a:off x="841248" y="5897880"/>
+            <a:endParaRPr lang="en-US" sz="1250" dirty="0"/>
+          </a:p>
+        </p:txBody>
+      </p:sp>
+      <p:sp>
+        <p:nvSpPr>
+          <p:cNvPr id="15" name="Shape 13"/>
+          <p:cNvSpPr/>
+          <p:nvPr/>
+        </p:nvSpPr>
+        <p:spPr>
+          <a:xfrm>
+            <a:off x="9857232" y="4736592"/>
+            <a:ext cx="1783080" cy="1783080"/>
+          </a:xfrm>
+          <a:prstGeom prst="roundRect">
+            <a:avLst>
+              <a:gd name="adj" fmla="val 3077"/>
+            </a:avLst>
+          </a:prstGeom>
+          <a:solidFill>
+            <a:srgbClr val="FFFFFF"/>
+          </a:solidFill>
+          <a:ln w="12700">
+            <a:solidFill>
+              <a:srgbClr val="FFFFFF"/>
+            </a:solidFill>
+            <a:prstDash val="solid"/>
+          </a:ln>
+        </p:spPr>
+      </p:sp>
+      <p:pic>
+        <p:nvPicPr>
+          <p:cNvPr id="16" name="Image 0" descr="qr.png">    </p:cNvPr>
+          <p:cNvPicPr>
+            <a:picLocks noChangeAspect="1"/>
+          </p:cNvPicPr>
+          <p:nvPr/>
+        </p:nvPicPr>
+        <p:blipFill>
+          <a:blip r:embed="rId1"/>
+          <a:stretch>
+            <a:fillRect/>
+          </a:stretch>
+        </p:blipFill>
+        <p:spPr>
+          <a:xfrm>
+            <a:off x="9966960" y="4846320"/>
+            <a:ext cx="1563624" cy="1563624"/>
+          </a:xfrm>
+          <a:prstGeom prst="rect">
+            <a:avLst/>
+          </a:prstGeom>
+        </p:spPr>
+      </p:pic>
+      <p:sp>
+        <p:nvSpPr>
+          <p:cNvPr id="17" name="Text 14"/>
+          <p:cNvSpPr txBox="1"/>
+          <p:nvPr/>
+        </p:nvSpPr>
+        <p:spPr>
+          <a:xfrm>
+            <a:off x="841248" y="4892040"/>
             <a:ext cx="4572000" cy="457200"/>
           </a:xfrm>
           <a:prstGeom prst="rect">
@@ -2841,14 +2892,14 @@
       </p:sp>
       <p:sp>
         <p:nvSpPr>
-          <p:cNvPr id="16" name="Text 14"/>
-          <p:cNvSpPr txBox="1"/>
-          <p:nvPr/>
-        </p:nvSpPr>
-        <p:spPr>
-          <a:xfrm>
-            <a:off x="5029200" y="5998464"/>
-            <a:ext cx="6400800" cy="365760"/>
+          <p:cNvPr id="18" name="Text 15"/>
+          <p:cNvSpPr txBox="1"/>
+          <p:nvPr/>
+        </p:nvSpPr>
+        <p:spPr>
+          <a:xfrm>
+            <a:off x="841248" y="5440680"/>
+            <a:ext cx="8229600" cy="320040"/>
           </a:xfrm>
           <a:prstGeom prst="rect">
             <a:avLst/>
@@ -2860,21 +2911,99 @@
           <a:bodyPr wrap="square" lIns="0" tIns="0" rIns="0" bIns="0" rtlCol="0" anchor="ctr"/>
           <a:lstStyle/>
           <a:p>
-            <a:pPr algn="r" indent="0" marL="0">
-              <a:buNone/>
-            </a:pPr>
-            <a:r>
-              <a:rPr lang="en-US" sz="1250" dirty="0">
-                <a:solidFill>
-                  <a:srgbClr val="7C8FA0"/>
+            <a:pPr indent="0" marL="0">
+              <a:buNone/>
+            </a:pPr>
+            <a:r>
+              <a:rPr lang="en-US" sz="1500" dirty="0">
+                <a:solidFill>
+                  <a:srgbClr val="FFFFFF"/>
                 </a:solidFill>
                 <a:latin typeface="Calibri" pitchFamily="34" charset="0"/>
                 <a:ea typeface="Calibri" pitchFamily="34" charset="-122"/>
                 <a:cs typeface="Calibri" pitchFamily="34" charset="-120"/>
               </a:rPr>
-              <a:t>concurrency-demo.onrender.com  ·  github.com/techadnank9/completablefuture-demo</a:t>
-            </a:r>
-            <a:endParaRPr lang="en-US" sz="1250" dirty="0"/>
+              <a:t>Scan it and race a file yourself</a:t>
+            </a:r>
+            <a:endParaRPr lang="en-US" sz="1500" dirty="0"/>
+          </a:p>
+        </p:txBody>
+      </p:sp>
+      <p:sp>
+        <p:nvSpPr>
+          <p:cNvPr id="19" name="Text 16"/>
+          <p:cNvSpPr txBox="1"/>
+          <p:nvPr/>
+        </p:nvSpPr>
+        <p:spPr>
+          <a:xfrm>
+            <a:off x="841248" y="5742432"/>
+            <a:ext cx="8229600" cy="292608"/>
+          </a:xfrm>
+          <a:prstGeom prst="rect">
+            <a:avLst/>
+          </a:prstGeom>
+          <a:noFill/>
+          <a:ln/>
+        </p:spPr>
+        <p:txBody>
+          <a:bodyPr wrap="square" lIns="0" tIns="0" rIns="0" bIns="0" rtlCol="0" anchor="ctr"/>
+          <a:lstStyle/>
+          <a:p>
+            <a:pPr indent="0" marL="0">
+              <a:buNone/>
+            </a:pPr>
+            <a:r>
+              <a:rPr lang="en-US" sz="1300" dirty="0">
+                <a:solidFill>
+                  <a:srgbClr val="00A896"/>
+                </a:solidFill>
+                <a:latin typeface="Courier New" pitchFamily="34" charset="0"/>
+                <a:ea typeface="Courier New" pitchFamily="34" charset="-122"/>
+                <a:cs typeface="Courier New" pitchFamily="34" charset="-120"/>
+              </a:rPr>
+              <a:t>concurrency-demo.onrender.com</a:t>
+            </a:r>
+            <a:endParaRPr lang="en-US" sz="1300" dirty="0"/>
+          </a:p>
+        </p:txBody>
+      </p:sp>
+      <p:sp>
+        <p:nvSpPr>
+          <p:cNvPr id="20" name="Text 17"/>
+          <p:cNvSpPr txBox="1"/>
+          <p:nvPr/>
+        </p:nvSpPr>
+        <p:spPr>
+          <a:xfrm>
+            <a:off x="841248" y="6053328"/>
+            <a:ext cx="8229600" cy="292608"/>
+          </a:xfrm>
+          <a:prstGeom prst="rect">
+            <a:avLst/>
+          </a:prstGeom>
+          <a:noFill/>
+          <a:ln/>
+        </p:spPr>
+        <p:txBody>
+          <a:bodyPr wrap="square" lIns="0" tIns="0" rIns="0" bIns="0" rtlCol="0" anchor="ctr"/>
+          <a:lstStyle/>
+          <a:p>
+            <a:pPr indent="0" marL="0">
+              <a:buNone/>
+            </a:pPr>
+            <a:r>
+              <a:rPr lang="en-US" sz="1200" dirty="0">
+                <a:solidFill>
+                  <a:srgbClr val="7C8FA0"/>
+                </a:solidFill>
+                <a:latin typeface="Courier New" pitchFamily="34" charset="0"/>
+                <a:ea typeface="Courier New" pitchFamily="34" charset="-122"/>
+                <a:cs typeface="Courier New" pitchFamily="34" charset="-120"/>
+              </a:rPr>
+              <a:t>github.com/techadnank9/completablefuture-demo</a:t>
+            </a:r>
+            <a:endParaRPr lang="en-US" sz="1200" dirty="0"/>
           </a:p>
         </p:txBody>
       </p:sp>
@@ -5444,7 +5573,7 @@
                 <a:ea typeface="Cambria" pitchFamily="34" charset="-122"/>
                 <a:cs typeface="Cambria" pitchFamily="34" charset="-120"/>
               </a:rPr>
-              <a:t>Same bytes. Same hash. Six times faster.</a:t>
+              <a:t>Same bytes. Same hash. Eight times faster.</a:t>
             </a:r>
             <a:endParaRPr lang="en-US" sz="3400" dirty="0"/>
           </a:p>
@@ -5483,7 +5612,7 @@
                 <a:ea typeface="Calibri" pitchFamily="34" charset="-122"/>
                 <a:cs typeface="Calibri" pitchFamily="34" charset="-120"/>
               </a:rPr>
-              <a:t>Both sides started at the same instant, against the same server, on the same connection.</a:t>
+              <a:t>One 8.97 MB photograph from the demo library, fetched by both sides at the same instant, against the same server, over the same connection.</a:t>
             </a:r>
             <a:endParaRPr lang="en-US" sz="1500" dirty="0"/>
           </a:p>
@@ -5627,7 +5756,7 @@
                 <a:ea typeface="Cambria" pitchFamily="34" charset="-122"/>
                 <a:cs typeface="Cambria" pitchFamily="34" charset="-120"/>
               </a:rPr>
-              <a:t>20.33 s</a:t>
+              <a:t>21.32 s</a:t>
             </a:r>
             <a:endParaRPr lang="en-US" sz="5000" dirty="0"/>
           </a:p>
@@ -5830,7 +5959,7 @@
                 <a:ea typeface="Cambria" pitchFamily="34" charset="-122"/>
                 <a:cs typeface="Cambria" pitchFamily="34" charset="-120"/>
               </a:rPr>
-              <a:t>3.35 s</a:t>
+              <a:t>2.61 s</a:t>
             </a:r>
             <a:endParaRPr lang="en-US" sz="5000" dirty="0"/>
           </a:p>
@@ -5869,7 +5998,7 @@
                 <a:ea typeface="Courier New" pitchFamily="34" charset="-122"/>
                 <a:cs typeface="Courier New" pitchFamily="34" charset="-120"/>
               </a:rPr>
-              <a:t>2.40 MB/s</a:t>
+              <a:t>3.30 MB/s</a:t>
             </a:r>
             <a:endParaRPr lang="en-US" sz="1300" dirty="0"/>
           </a:p>
@@ -6068,7 +6197,7 @@
                 <a:ea typeface="Calibri" pitchFamily="34" charset="-122"/>
                 <a:cs typeface="Calibri" pitchFamily="34" charset="-120"/>
               </a:rPr>
-              <a:t>6.1× faster</a:t>
+              <a:t>8.2× faster</a:t>
             </a:r>
             <a:pPr indent="0" marL="0">
               <a:buNone/>
@@ -6082,7 +6211,7 @@
                 <a:ea typeface="Calibri" pitchFamily="34" charset="-122"/>
                 <a:cs typeface="Calibri" pitchFamily="34" charset="-120"/>
               </a:rPr>
-              <a:t>    SHA-256   1d31…724f  =  1d31…724f   identical</a:t>
+              <a:t>    SHA-256   bc6f…c055  =  bc6f…c055   identical</a:t>
             </a:r>
             <a:endParaRPr lang="en-US" sz="2200" dirty="0"/>
           </a:p>

</xml_diff>